<commit_message>
feat: update apresentacao.pptx with qrcode
</commit_message>
<xml_diff>
--- a/apresentacao.pptx
+++ b/apresentacao.pptx
@@ -1,6 +1,6 @@
 
 <file path=ppt/presentation.xml><?xml version="1.0" encoding="utf-8"?>
-<p:presentation xmlns:a="http://schemas.openxmlformats.org/drawingml/2006/main" xmlns:r="http://schemas.openxmlformats.org/officeDocument/2006/relationships" xmlns:p="http://schemas.openxmlformats.org/presentationml/2006/main" embedTrueTypeFonts="1" saveSubsetFonts="1">
+<p:presentation xmlns:a="http://schemas.openxmlformats.org/drawingml/2006/main" xmlns:r="http://schemas.openxmlformats.org/officeDocument/2006/relationships" xmlns:p="http://schemas.openxmlformats.org/presentationml/2006/main" saveSubsetFonts="1" embedTrueTypeFonts="1">
   <p:sldMasterIdLst>
     <p:sldMasterId id="2147483648" r:id="rId1"/>
   </p:sldMasterIdLst>
@@ -12,48 +12,48 @@
     <p:sldId id="260" r:id="rId6"/>
     <p:sldId id="261" r:id="rId7"/>
     <p:sldId id="262" r:id="rId8"/>
-    <p:sldId id="277" r:id="rId9"/>
-    <p:sldId id="263" r:id="rId10"/>
-    <p:sldId id="264" r:id="rId11"/>
-    <p:sldId id="265" r:id="rId12"/>
-    <p:sldId id="266" r:id="rId13"/>
-    <p:sldId id="278" r:id="rId14"/>
-    <p:sldId id="267" r:id="rId15"/>
-    <p:sldId id="268" r:id="rId16"/>
-    <p:sldId id="269" r:id="rId17"/>
-    <p:sldId id="270" r:id="rId18"/>
-    <p:sldId id="279" r:id="rId19"/>
-    <p:sldId id="271" r:id="rId20"/>
-    <p:sldId id="272" r:id="rId21"/>
-    <p:sldId id="273" r:id="rId22"/>
-    <p:sldId id="274" r:id="rId23"/>
-    <p:sldId id="280" r:id="rId24"/>
-    <p:sldId id="275" r:id="rId25"/>
-    <p:sldId id="276" r:id="rId26"/>
+    <p:sldId id="263" r:id="rId9"/>
+    <p:sldId id="264" r:id="rId10"/>
+    <p:sldId id="265" r:id="rId11"/>
+    <p:sldId id="266" r:id="rId12"/>
+    <p:sldId id="267" r:id="rId13"/>
+    <p:sldId id="268" r:id="rId14"/>
+    <p:sldId id="269" r:id="rId15"/>
+    <p:sldId id="270" r:id="rId16"/>
+    <p:sldId id="271" r:id="rId17"/>
+    <p:sldId id="272" r:id="rId18"/>
+    <p:sldId id="273" r:id="rId19"/>
+    <p:sldId id="274" r:id="rId20"/>
+    <p:sldId id="275" r:id="rId21"/>
+    <p:sldId id="276" r:id="rId22"/>
+    <p:sldId id="277" r:id="rId23"/>
+    <p:sldId id="278" r:id="rId24"/>
+    <p:sldId id="279" r:id="rId25"/>
+    <p:sldId id="280" r:id="rId26"/>
   </p:sldIdLst>
   <p:sldSz cx="12192000" cy="6858000"/>
   <p:notesSz cx="6858000" cy="9144000"/>
   <p:embeddedFontLst>
     <p:embeddedFont>
       <p:font typeface="JetBrains Mono" panose="020B0604020202020204" charset="0"/>
-      <p:regular r:id="rId27"/>
-      <p:bold r:id="rId28"/>
-      <p:italic r:id="rId29"/>
-      <p:boldItalic r:id="rId30"/>
+      <p:regular r:id="rId31"/>
+      <p:bold r:id="rId32"/>
+      <p:italic r:id="rId33"/>
+      <p:boldItalic r:id="rId34"/>
     </p:embeddedFont>
     <p:embeddedFont>
       <p:font typeface="Plus Jakarta Sans" panose="020B0604020202020204" charset="0"/>
-      <p:regular r:id="rId31"/>
-      <p:bold r:id="rId32"/>
-      <p:italic r:id="rId33"/>
-      <p:boldItalic r:id="rId31"/>
+      <p:regular r:id="rId35"/>
+      <p:bold r:id="rId36"/>
+      <p:italic r:id="rId37"/>
+      <p:boldItalic r:id="rId35"/>
     </p:embeddedFont>
     <p:embeddedFont>
       <p:font typeface="Roboto Mono" panose="00000009000000000000" pitchFamily="49" charset="0"/>
-      <p:regular r:id="rId34"/>
-      <p:bold r:id="rId35"/>
-      <p:italic r:id="rId36"/>
-      <p:boldItalic r:id="rId37"/>
+      <p:regular r:id="rId38"/>
+      <p:bold r:id="rId39"/>
+      <p:italic r:id="rId40"/>
+      <p:boldItalic r:id="rId41"/>
     </p:embeddedFont>
   </p:embeddedFontLst>
   <p:defaultTextStyle>
@@ -133,14 +133,6 @@
 </p:presentation>
 </file>
 
-<file path=ppt/revisionInfo.xml><?xml version="1.0" encoding="utf-8"?>
-<p1510:revInfo xmlns:a="http://schemas.openxmlformats.org/drawingml/2006/main" xmlns:r="http://schemas.openxmlformats.org/officeDocument/2006/relationships" xmlns:p1510="http://schemas.microsoft.com/office/powerpoint/2015/10/main">
-  <p1510:revLst>
-    <p1510:client id="{2EF50765-7AD4-4B49-824F-FAA03006ED3F}" v="77" dt="2026-10-27T18:57:06.508"/>
-  </p1510:revLst>
-</p1510:revInfo>
-</file>
-
 <file path=ppt/slideLayouts/slideLayout1.xml><?xml version="1.0" encoding="utf-8"?>
 <p:sldLayout xmlns:a="http://schemas.openxmlformats.org/drawingml/2006/main" xmlns:r="http://schemas.openxmlformats.org/officeDocument/2006/relationships" xmlns:p="http://schemas.openxmlformats.org/presentationml/2006/main" type="blank" preserve="1">
   <p:cSld name="BLANK">
@@ -2240,8 +2232,8 @@
           <a:bodyPr/>
           <a:lstStyle/>
           <a:p>
-            <a:fld id="{5BCAD085-E8A6-8845-BD4E-CB4CCA059FC4}" type="datetimeFigureOut">
-              <a:rPr lang="en-US" smtClean="0"/>
+            <a:fld id="{BC524192-8E8D-414D-8EE0-97276B7B69C6}" type="datetimeFigureOut">
+              <a:rPr lang="en-US"/>
               <a:t>10/27/2026</a:t>
             </a:fld>
             <a:endParaRPr lang="en-US"/>
@@ -2282,8 +2274,8 @@
           <a:bodyPr/>
           <a:lstStyle/>
           <a:p>
-            <a:fld id="{C1FF6DA9-008F-8B48-92A6-B652298478BF}" type="slidenum">
-              <a:rPr lang="en-US" smtClean="0"/>
+            <a:fld id="{EDC07AEC-4DB1-4201-8352-72C66BEDFD24}" type="slidenum">
+              <a:rPr lang="en-US"/>
               <a:t>‹nº›</a:t>
             </a:fld>
             <a:endParaRPr lang="en-US"/>
@@ -2291,11 +2283,6 @@
         </p:txBody>
       </p:sp>
     </p:spTree>
-    <p:extLst>
-      <p:ext uri="{BB962C8B-B14F-4D97-AF65-F5344CB8AC3E}">
-        <p14:creationId xmlns:p14="http://schemas.microsoft.com/office/powerpoint/2010/main" val="1857074910"/>
-      </p:ext>
-    </p:extLst>
   </p:cSld>
   <p:clrMapOvr>
     <a:masterClrMapping/>
@@ -7809,7 +7796,7 @@
         </p:nvSpPr>
         <p:spPr>
           <a:xfrm>
-            <a:off x="8382000" y="6019800"/>
+            <a:off x="8534400" y="6248400"/>
             <a:ext cx="3431160" cy="402336"/>
           </a:xfrm>
           <a:prstGeom prst="rect">
@@ -7917,6 +7904,30 @@
           </a:p>
         </p:txBody>
       </p:sp>
+      <p:pic>
+        <p:nvPicPr>
+          <p:cNvPr id="414" name="Picture 3" descr="extended.png"/>
+          <p:cNvPicPr>
+            <a:picLocks noChangeAspect="1"/>
+          </p:cNvPicPr>
+          <p:nvPr/>
+        </p:nvPicPr>
+        <p:blipFill rotWithShape="1">
+          <a:blip r:embed="rId2"/>
+          <a:stretch>
+            <a:fillRect/>
+          </a:stretch>
+        </p:blipFill>
+        <p:spPr>
+          <a:xfrm>
+            <a:off x="609600" y="685800"/>
+            <a:ext cx="10972800" cy="5486400"/>
+          </a:xfrm>
+          <a:prstGeom prst="rect">
+            <a:avLst/>
+          </a:prstGeom>
+        </p:spPr>
+      </p:pic>
     </p:spTree>
   </p:cSld>
   <p:clrMapOvr>
@@ -11126,7 +11137,6 @@
           <a:lstStyle/>
           <a:p>
             <a:pPr algn="ctr"/>
-            <a:endParaRPr/>
           </a:p>
         </p:txBody>
       </p:sp>
@@ -11175,7 +11185,6 @@
           <a:lstStyle/>
           <a:p>
             <a:pPr algn="ctr"/>
-            <a:endParaRPr/>
           </a:p>
         </p:txBody>
       </p:sp>
@@ -11224,7 +11233,6 @@
           <a:lstStyle/>
           <a:p>
             <a:pPr algn="ctr"/>
-            <a:endParaRPr/>
           </a:p>
         </p:txBody>
       </p:sp>
@@ -11269,7 +11277,6 @@
           <a:lstStyle/>
           <a:p>
             <a:pPr algn="ctr"/>
-            <a:endParaRPr/>
           </a:p>
         </p:txBody>
       </p:sp>
@@ -11314,7 +11321,6 @@
           <a:lstStyle/>
           <a:p>
             <a:pPr algn="ctr"/>
-            <a:endParaRPr/>
           </a:p>
         </p:txBody>
       </p:sp>
@@ -11359,7 +11365,6 @@
           <a:lstStyle/>
           <a:p>
             <a:pPr algn="ctr"/>
-            <a:endParaRPr/>
           </a:p>
         </p:txBody>
       </p:sp>
@@ -11404,7 +11409,6 @@
           <a:lstStyle/>
           <a:p>
             <a:pPr algn="ctr"/>
-            <a:endParaRPr/>
           </a:p>
         </p:txBody>
       </p:sp>
@@ -11449,7 +11453,6 @@
           <a:lstStyle/>
           <a:p>
             <a:pPr algn="ctr"/>
-            <a:endParaRPr/>
           </a:p>
         </p:txBody>
       </p:sp>
@@ -11494,7 +11497,6 @@
           <a:lstStyle/>
           <a:p>
             <a:pPr algn="ctr"/>
-            <a:endParaRPr/>
           </a:p>
         </p:txBody>
       </p:sp>
@@ -11506,7 +11508,7 @@
           </p:cNvPicPr>
           <p:nvPr/>
         </p:nvPicPr>
-        <p:blipFill>
+        <p:blipFill rotWithShape="1">
           <a:blip r:embed="rId2"/>
           <a:stretch>
             <a:fillRect/>
@@ -11530,7 +11532,7 @@
           </p:cNvPicPr>
           <p:nvPr/>
         </p:nvPicPr>
-        <p:blipFill>
+        <p:blipFill rotWithShape="1">
           <a:blip r:embed="rId3"/>
           <a:stretch>
             <a:fillRect/>
@@ -11554,7 +11556,7 @@
           </p:cNvPicPr>
           <p:nvPr/>
         </p:nvPicPr>
-        <p:blipFill>
+        <p:blipFill rotWithShape="1">
           <a:blip r:embed="rId4"/>
           <a:stretch>
             <a:fillRect/>
@@ -11938,13 +11940,7 @@
       </p:sp>
       <p:sp>
         <p:nvSpPr>
-          <p:cNvPr id="28" name="Google Shape;218;p22">
-            <a:extLst>
-              <a:ext uri="{FF2B5EF4-FFF2-40B4-BE49-F238E27FC236}">
-                <a16:creationId xmlns:a16="http://schemas.microsoft.com/office/drawing/2014/main" id="{2E46DBAD-AE6A-16D6-EA3C-C4A37B37E8FD}"/>
-              </a:ext>
-            </a:extLst>
-          </p:cNvPr>
+          <p:cNvPr id="28" name="Google Shape;218;p22"/>
           <p:cNvSpPr/>
           <p:nvPr/>
         </p:nvSpPr>
@@ -12008,13 +12004,7 @@
       </p:sp>
       <p:sp>
         <p:nvSpPr>
-          <p:cNvPr id="30" name="Google Shape;219;p22">
-            <a:extLst>
-              <a:ext uri="{FF2B5EF4-FFF2-40B4-BE49-F238E27FC236}">
-                <a16:creationId xmlns:a16="http://schemas.microsoft.com/office/drawing/2014/main" id="{9B2AE57D-5D9F-B5B0-40E1-C14563422719}"/>
-              </a:ext>
-            </a:extLst>
-          </p:cNvPr>
+          <p:cNvPr id="30" name="Google Shape;219;p22"/>
           <p:cNvSpPr/>
           <p:nvPr/>
         </p:nvSpPr>
@@ -12055,7 +12045,7 @@
               </a:tabLst>
             </a:pPr>
             <a:r>
-              <a:rPr lang="en-US" sz="2400" b="1" dirty="0">
+              <a:rPr lang="en-US" sz="2400" b="1">
                 <a:solidFill>
                   <a:srgbClr val="0F172A"/>
                 </a:solidFill>
@@ -12064,7 +12054,7 @@
               <a:t>Chain of Responsibility: </a:t>
             </a:r>
             <a:r>
-              <a:rPr lang="en-US" sz="2400" b="1" dirty="0" err="1">
+              <a:rPr lang="en-US" sz="2400" b="1">
                 <a:solidFill>
                   <a:srgbClr val="0F172A"/>
                 </a:solidFill>
@@ -12073,7 +12063,7 @@
               <a:t>Perguntas</a:t>
             </a:r>
             <a:r>
-              <a:rPr lang="en-US" sz="2400" b="1" dirty="0">
+              <a:rPr lang="en-US" sz="2400" b="1">
                 <a:solidFill>
                   <a:srgbClr val="0F172A"/>
                 </a:solidFill>
@@ -12082,7 +12072,7 @@
               <a:t> </a:t>
             </a:r>
             <a:r>
-              <a:rPr lang="en-US" sz="2400" b="1" dirty="0" err="1">
+              <a:rPr lang="en-US" sz="2400" b="1">
                 <a:solidFill>
                   <a:srgbClr val="0F172A"/>
                 </a:solidFill>
@@ -12090,7 +12080,7 @@
               </a:rPr>
               <a:t>Frequentes</a:t>
             </a:r>
-            <a:endParaRPr lang="en-US" sz="2400" dirty="0" err="1">
+            <a:endParaRPr lang="en-US" sz="2400">
               <a:solidFill>
                 <a:srgbClr val="000000"/>
               </a:solidFill>
@@ -12100,11 +12090,6 @@
         </p:txBody>
       </p:sp>
     </p:spTree>
-    <p:extLst>
-      <p:ext uri="{BB962C8B-B14F-4D97-AF65-F5344CB8AC3E}">
-        <p14:creationId xmlns:p14="http://schemas.microsoft.com/office/powerpoint/2010/main" val="4231526154"/>
-      </p:ext>
-    </p:extLst>
   </p:cSld>
   <p:clrMapOvr>
     <a:masterClrMapping/>
@@ -15416,7 +15401,6 @@
           <a:lstStyle/>
           <a:p>
             <a:pPr algn="ctr"/>
-            <a:endParaRPr/>
           </a:p>
         </p:txBody>
       </p:sp>
@@ -15465,7 +15449,6 @@
           <a:lstStyle/>
           <a:p>
             <a:pPr algn="ctr"/>
-            <a:endParaRPr/>
           </a:p>
         </p:txBody>
       </p:sp>
@@ -15514,7 +15497,6 @@
           <a:lstStyle/>
           <a:p>
             <a:pPr algn="ctr"/>
-            <a:endParaRPr/>
           </a:p>
         </p:txBody>
       </p:sp>
@@ -15559,7 +15541,6 @@
           <a:lstStyle/>
           <a:p>
             <a:pPr algn="ctr"/>
-            <a:endParaRPr/>
           </a:p>
         </p:txBody>
       </p:sp>
@@ -15604,7 +15585,6 @@
           <a:lstStyle/>
           <a:p>
             <a:pPr algn="ctr"/>
-            <a:endParaRPr/>
           </a:p>
         </p:txBody>
       </p:sp>
@@ -15649,7 +15629,6 @@
           <a:lstStyle/>
           <a:p>
             <a:pPr algn="ctr"/>
-            <a:endParaRPr/>
           </a:p>
         </p:txBody>
       </p:sp>
@@ -15694,7 +15673,6 @@
           <a:lstStyle/>
           <a:p>
             <a:pPr algn="ctr"/>
-            <a:endParaRPr/>
           </a:p>
         </p:txBody>
       </p:sp>
@@ -15739,7 +15717,6 @@
           <a:lstStyle/>
           <a:p>
             <a:pPr algn="ctr"/>
-            <a:endParaRPr/>
           </a:p>
         </p:txBody>
       </p:sp>
@@ -15784,7 +15761,6 @@
           <a:lstStyle/>
           <a:p>
             <a:pPr algn="ctr"/>
-            <a:endParaRPr/>
           </a:p>
         </p:txBody>
       </p:sp>
@@ -15796,7 +15772,7 @@
           </p:cNvPicPr>
           <p:nvPr/>
         </p:nvPicPr>
-        <p:blipFill>
+        <p:blipFill rotWithShape="1">
           <a:blip r:embed="rId2"/>
           <a:stretch>
             <a:fillRect/>
@@ -15820,7 +15796,7 @@
           </p:cNvPicPr>
           <p:nvPr/>
         </p:nvPicPr>
-        <p:blipFill>
+        <p:blipFill rotWithShape="1">
           <a:blip r:embed="rId3"/>
           <a:stretch>
             <a:fillRect/>
@@ -15844,7 +15820,7 @@
           </p:cNvPicPr>
           <p:nvPr/>
         </p:nvPicPr>
-        <p:blipFill>
+        <p:blipFill rotWithShape="1">
           <a:blip r:embed="rId4"/>
           <a:stretch>
             <a:fillRect/>
@@ -16264,13 +16240,7 @@
       </p:sp>
       <p:sp>
         <p:nvSpPr>
-          <p:cNvPr id="28" name="Google Shape;272;p26">
-            <a:extLst>
-              <a:ext uri="{FF2B5EF4-FFF2-40B4-BE49-F238E27FC236}">
-                <a16:creationId xmlns:a16="http://schemas.microsoft.com/office/drawing/2014/main" id="{C97C7D91-E6B9-6277-F2E4-5C5CAA6EF74B}"/>
-              </a:ext>
-            </a:extLst>
-          </p:cNvPr>
+          <p:cNvPr id="28" name="Google Shape;272;p26"/>
           <p:cNvSpPr/>
           <p:nvPr/>
         </p:nvSpPr>
@@ -16334,13 +16304,7 @@
       </p:sp>
       <p:sp>
         <p:nvSpPr>
-          <p:cNvPr id="30" name="Google Shape;273;p26">
-            <a:extLst>
-              <a:ext uri="{FF2B5EF4-FFF2-40B4-BE49-F238E27FC236}">
-                <a16:creationId xmlns:a16="http://schemas.microsoft.com/office/drawing/2014/main" id="{4CFB4248-0720-96A9-C48D-BBCFE8F412D1}"/>
-              </a:ext>
-            </a:extLst>
-          </p:cNvPr>
+          <p:cNvPr id="30" name="Google Shape;273;p26"/>
           <p:cNvSpPr/>
           <p:nvPr/>
         </p:nvSpPr>
@@ -16381,7 +16345,7 @@
               </a:tabLst>
             </a:pPr>
             <a:r>
-              <a:rPr lang="en-US" sz="2400" b="1" dirty="0">
+              <a:rPr lang="en-US" sz="2400" b="1">
                 <a:solidFill>
                   <a:srgbClr val="0F172A"/>
                 </a:solidFill>
@@ -16390,7 +16354,7 @@
               <a:t>Command Pattern: </a:t>
             </a:r>
             <a:r>
-              <a:rPr lang="en-US" sz="2400" b="1" dirty="0" err="1">
+              <a:rPr lang="en-US" sz="2400" b="1">
                 <a:solidFill>
                   <a:srgbClr val="0F172A"/>
                 </a:solidFill>
@@ -16399,7 +16363,7 @@
               <a:t>Perguntas</a:t>
             </a:r>
             <a:r>
-              <a:rPr lang="en-US" sz="2400" b="1" dirty="0">
+              <a:rPr lang="en-US" sz="2400" b="1">
                 <a:solidFill>
                   <a:srgbClr val="0F172A"/>
                 </a:solidFill>
@@ -16427,11 +16391,6 @@
         </p:txBody>
       </p:sp>
     </p:spTree>
-    <p:extLst>
-      <p:ext uri="{BB962C8B-B14F-4D97-AF65-F5344CB8AC3E}">
-        <p14:creationId xmlns:p14="http://schemas.microsoft.com/office/powerpoint/2010/main" val="4246317199"/>
-      </p:ext>
-    </p:extLst>
   </p:cSld>
   <p:clrMapOvr>
     <a:masterClrMapping/>
@@ -20852,7 +20811,6 @@
           <a:lstStyle/>
           <a:p>
             <a:pPr algn="ctr"/>
-            <a:endParaRPr/>
           </a:p>
         </p:txBody>
       </p:sp>
@@ -20901,7 +20859,6 @@
           <a:lstStyle/>
           <a:p>
             <a:pPr algn="ctr"/>
-            <a:endParaRPr/>
           </a:p>
         </p:txBody>
       </p:sp>
@@ -20950,7 +20907,6 @@
           <a:lstStyle/>
           <a:p>
             <a:pPr algn="ctr"/>
-            <a:endParaRPr/>
           </a:p>
         </p:txBody>
       </p:sp>
@@ -20995,7 +20951,6 @@
           <a:lstStyle/>
           <a:p>
             <a:pPr algn="ctr"/>
-            <a:endParaRPr/>
           </a:p>
         </p:txBody>
       </p:sp>
@@ -21040,7 +20995,6 @@
           <a:lstStyle/>
           <a:p>
             <a:pPr algn="ctr"/>
-            <a:endParaRPr/>
           </a:p>
         </p:txBody>
       </p:sp>
@@ -21085,7 +21039,6 @@
           <a:lstStyle/>
           <a:p>
             <a:pPr algn="ctr"/>
-            <a:endParaRPr/>
           </a:p>
         </p:txBody>
       </p:sp>
@@ -21130,7 +21083,6 @@
           <a:lstStyle/>
           <a:p>
             <a:pPr algn="ctr"/>
-            <a:endParaRPr/>
           </a:p>
         </p:txBody>
       </p:sp>
@@ -21175,7 +21127,6 @@
           <a:lstStyle/>
           <a:p>
             <a:pPr algn="ctr"/>
-            <a:endParaRPr/>
           </a:p>
         </p:txBody>
       </p:sp>
@@ -21220,7 +21171,6 @@
           <a:lstStyle/>
           <a:p>
             <a:pPr algn="ctr"/>
-            <a:endParaRPr/>
           </a:p>
         </p:txBody>
       </p:sp>
@@ -21232,7 +21182,7 @@
           </p:cNvPicPr>
           <p:nvPr/>
         </p:nvPicPr>
-        <p:blipFill>
+        <p:blipFill rotWithShape="1">
           <a:blip r:embed="rId2"/>
           <a:stretch>
             <a:fillRect/>
@@ -21256,7 +21206,7 @@
           </p:cNvPicPr>
           <p:nvPr/>
         </p:nvPicPr>
-        <p:blipFill>
+        <p:blipFill rotWithShape="1">
           <a:blip r:embed="rId3"/>
           <a:stretch>
             <a:fillRect/>
@@ -21280,7 +21230,7 @@
           </p:cNvPicPr>
           <p:nvPr/>
         </p:nvPicPr>
-        <p:blipFill>
+        <p:blipFill rotWithShape="1">
           <a:blip r:embed="rId4"/>
           <a:stretch>
             <a:fillRect/>
@@ -21664,13 +21614,7 @@
       </p:sp>
       <p:sp>
         <p:nvSpPr>
-          <p:cNvPr id="28" name="Google Shape;326;p30">
-            <a:extLst>
-              <a:ext uri="{FF2B5EF4-FFF2-40B4-BE49-F238E27FC236}">
-                <a16:creationId xmlns:a16="http://schemas.microsoft.com/office/drawing/2014/main" id="{162E8E07-9038-2682-FCEF-BAC8DD15F953}"/>
-              </a:ext>
-            </a:extLst>
-          </p:cNvPr>
+          <p:cNvPr id="28" name="Google Shape;326;p30"/>
           <p:cNvSpPr/>
           <p:nvPr/>
         </p:nvSpPr>
@@ -21734,13 +21678,7 @@
       </p:sp>
       <p:sp>
         <p:nvSpPr>
-          <p:cNvPr id="30" name="Google Shape;327;p30">
-            <a:extLst>
-              <a:ext uri="{FF2B5EF4-FFF2-40B4-BE49-F238E27FC236}">
-                <a16:creationId xmlns:a16="http://schemas.microsoft.com/office/drawing/2014/main" id="{F26BF6ED-497E-412A-8D2F-9B902AED3445}"/>
-              </a:ext>
-            </a:extLst>
-          </p:cNvPr>
+          <p:cNvPr id="30" name="Google Shape;327;p30"/>
           <p:cNvSpPr/>
           <p:nvPr/>
         </p:nvSpPr>
@@ -21781,7 +21719,7 @@
               </a:tabLst>
             </a:pPr>
             <a:r>
-              <a:rPr lang="en-US" sz="2400" b="1" dirty="0">
+              <a:rPr lang="en-US" sz="2400" b="1">
                 <a:solidFill>
                   <a:srgbClr val="0F172A"/>
                 </a:solidFill>
@@ -21790,7 +21728,7 @@
               <a:t>Interface Segregation Principle: </a:t>
             </a:r>
             <a:r>
-              <a:rPr lang="en-US" sz="2400" b="1" dirty="0" err="1">
+              <a:rPr lang="en-US" sz="2400" b="1">
                 <a:solidFill>
                   <a:srgbClr val="0F172A"/>
                 </a:solidFill>
@@ -21799,7 +21737,7 @@
               <a:t>Perguntas</a:t>
             </a:r>
             <a:r>
-              <a:rPr lang="en-US" sz="2400" b="1" dirty="0">
+              <a:rPr lang="en-US" sz="2400" b="1">
                 <a:solidFill>
                   <a:srgbClr val="0F172A"/>
                 </a:solidFill>
@@ -21808,7 +21746,7 @@
               <a:t> </a:t>
             </a:r>
             <a:r>
-              <a:rPr lang="en-US" sz="2400" b="1" dirty="0" err="1">
+              <a:rPr lang="en-US" sz="2400" b="1">
                 <a:solidFill>
                   <a:srgbClr val="0F172A"/>
                 </a:solidFill>
@@ -21816,7 +21754,7 @@
               </a:rPr>
               <a:t>Frequentes</a:t>
             </a:r>
-            <a:endParaRPr lang="en-US" sz="2400" dirty="0" err="1">
+            <a:endParaRPr lang="en-US" sz="2400">
               <a:solidFill>
                 <a:srgbClr val="000000"/>
               </a:solidFill>
@@ -21826,11 +21764,6 @@
         </p:txBody>
       </p:sp>
     </p:spTree>
-    <p:extLst>
-      <p:ext uri="{BB962C8B-B14F-4D97-AF65-F5344CB8AC3E}">
-        <p14:creationId xmlns:p14="http://schemas.microsoft.com/office/powerpoint/2010/main" val="2131429667"/>
-      </p:ext>
-    </p:extLst>
   </p:cSld>
   <p:clrMapOvr>
     <a:masterClrMapping/>
@@ -21882,34 +21815,10 @@
                 <a:tableStyleId>{5940675A-B579-460E-94D1-54222C63F5DA}</a:tableStyleId>
               </a:tblPr>
               <a:tblGrid>
-                <a:gridCol w="1694520">
-                  <a:extLst>
-                    <a:ext uri="{9D8B030D-6E8A-4147-A177-3AD203B41FA5}">
-                      <a16:colId xmlns:a16="http://schemas.microsoft.com/office/drawing/2014/main" val="20000"/>
-                    </a:ext>
-                  </a:extLst>
-                </a:gridCol>
-                <a:gridCol w="2782080">
-                  <a:extLst>
-                    <a:ext uri="{9D8B030D-6E8A-4147-A177-3AD203B41FA5}">
-                      <a16:colId xmlns:a16="http://schemas.microsoft.com/office/drawing/2014/main" val="20001"/>
-                    </a:ext>
-                  </a:extLst>
-                </a:gridCol>
-                <a:gridCol w="3357360">
-                  <a:extLst>
-                    <a:ext uri="{9D8B030D-6E8A-4147-A177-3AD203B41FA5}">
-                      <a16:colId xmlns:a16="http://schemas.microsoft.com/office/drawing/2014/main" val="20002"/>
-                    </a:ext>
-                  </a:extLst>
-                </a:gridCol>
-                <a:gridCol w="3138120">
-                  <a:extLst>
-                    <a:ext uri="{9D8B030D-6E8A-4147-A177-3AD203B41FA5}">
-                      <a16:colId xmlns:a16="http://schemas.microsoft.com/office/drawing/2014/main" val="20003"/>
-                    </a:ext>
-                  </a:extLst>
-                </a:gridCol>
+                <a:gridCol w="1694520"/>
+                <a:gridCol w="2782080"/>
+                <a:gridCol w="3357360"/>
+                <a:gridCol w="3138120"/>
               </a:tblGrid>
               <a:tr h="514080">
                 <a:tc>
@@ -22188,11 +22097,6 @@
                     </a:solidFill>
                   </a:tcPr>
                 </a:tc>
-                <a:extLst>
-                  <a:ext uri="{0D108BD9-81ED-4DB2-BD59-A6C34878D82A}">
-                    <a16:rowId xmlns:a16="http://schemas.microsoft.com/office/drawing/2014/main" val="10000"/>
-                  </a:ext>
-                </a:extLst>
               </a:tr>
               <a:tr h="514080">
                 <a:tc>
@@ -22471,11 +22375,6 @@
                     </a:solidFill>
                   </a:tcPr>
                 </a:tc>
-                <a:extLst>
-                  <a:ext uri="{0D108BD9-81ED-4DB2-BD59-A6C34878D82A}">
-                    <a16:rowId xmlns:a16="http://schemas.microsoft.com/office/drawing/2014/main" val="10001"/>
-                  </a:ext>
-                </a:extLst>
               </a:tr>
               <a:tr h="514080">
                 <a:tc>
@@ -22754,11 +22653,6 @@
                     </a:solidFill>
                   </a:tcPr>
                 </a:tc>
-                <a:extLst>
-                  <a:ext uri="{0D108BD9-81ED-4DB2-BD59-A6C34878D82A}">
-                    <a16:rowId xmlns:a16="http://schemas.microsoft.com/office/drawing/2014/main" val="10002"/>
-                  </a:ext>
-                </a:extLst>
               </a:tr>
               <a:tr h="514080">
                 <a:tc>
@@ -23037,11 +22931,6 @@
                     </a:solidFill>
                   </a:tcPr>
                 </a:tc>
-                <a:extLst>
-                  <a:ext uri="{0D108BD9-81ED-4DB2-BD59-A6C34878D82A}">
-                    <a16:rowId xmlns:a16="http://schemas.microsoft.com/office/drawing/2014/main" val="10003"/>
-                  </a:ext>
-                </a:extLst>
               </a:tr>
               <a:tr h="514080">
                 <a:tc>
@@ -23320,11 +23209,6 @@
                     </a:solidFill>
                   </a:tcPr>
                 </a:tc>
-                <a:extLst>
-                  <a:ext uri="{0D108BD9-81ED-4DB2-BD59-A6C34878D82A}">
-                    <a16:rowId xmlns:a16="http://schemas.microsoft.com/office/drawing/2014/main" val="10004"/>
-                  </a:ext>
-                </a:extLst>
               </a:tr>
             </a:tbl>
           </a:graphicData>
@@ -27953,7 +27837,6 @@
           <a:lstStyle/>
           <a:p>
             <a:pPr algn="ctr"/>
-            <a:endParaRPr/>
           </a:p>
         </p:txBody>
       </p:sp>
@@ -28002,7 +27885,6 @@
           <a:lstStyle/>
           <a:p>
             <a:pPr algn="ctr"/>
-            <a:endParaRPr/>
           </a:p>
         </p:txBody>
       </p:sp>
@@ -28051,7 +27933,6 @@
           <a:lstStyle/>
           <a:p>
             <a:pPr algn="ctr"/>
-            <a:endParaRPr/>
           </a:p>
         </p:txBody>
       </p:sp>
@@ -28096,7 +27977,6 @@
           <a:lstStyle/>
           <a:p>
             <a:pPr algn="ctr"/>
-            <a:endParaRPr/>
           </a:p>
         </p:txBody>
       </p:sp>
@@ -28141,7 +28021,6 @@
           <a:lstStyle/>
           <a:p>
             <a:pPr algn="ctr"/>
-            <a:endParaRPr/>
           </a:p>
         </p:txBody>
       </p:sp>
@@ -28186,7 +28065,6 @@
           <a:lstStyle/>
           <a:p>
             <a:pPr algn="ctr"/>
-            <a:endParaRPr/>
           </a:p>
         </p:txBody>
       </p:sp>
@@ -28231,7 +28109,6 @@
           <a:lstStyle/>
           <a:p>
             <a:pPr algn="ctr"/>
-            <a:endParaRPr/>
           </a:p>
         </p:txBody>
       </p:sp>
@@ -28276,7 +28153,6 @@
           <a:lstStyle/>
           <a:p>
             <a:pPr algn="ctr"/>
-            <a:endParaRPr/>
           </a:p>
         </p:txBody>
       </p:sp>
@@ -28321,7 +28197,6 @@
           <a:lstStyle/>
           <a:p>
             <a:pPr algn="ctr"/>
-            <a:endParaRPr/>
           </a:p>
         </p:txBody>
       </p:sp>
@@ -28333,7 +28208,7 @@
           </p:cNvPicPr>
           <p:nvPr/>
         </p:nvPicPr>
-        <p:blipFill>
+        <p:blipFill rotWithShape="1">
           <a:blip r:embed="rId2"/>
           <a:stretch>
             <a:fillRect/>
@@ -28357,7 +28232,7 @@
           </p:cNvPicPr>
           <p:nvPr/>
         </p:nvPicPr>
-        <p:blipFill>
+        <p:blipFill rotWithShape="1">
           <a:blip r:embed="rId3"/>
           <a:stretch>
             <a:fillRect/>
@@ -28381,7 +28256,7 @@
           </p:cNvPicPr>
           <p:nvPr/>
         </p:nvPicPr>
-        <p:blipFill>
+        <p:blipFill rotWithShape="1">
           <a:blip r:embed="rId4"/>
           <a:stretch>
             <a:fillRect/>
@@ -28765,13 +28640,7 @@
       </p:sp>
       <p:sp>
         <p:nvSpPr>
-          <p:cNvPr id="28" name="Google Shape;138;p16">
-            <a:extLst>
-              <a:ext uri="{FF2B5EF4-FFF2-40B4-BE49-F238E27FC236}">
-                <a16:creationId xmlns:a16="http://schemas.microsoft.com/office/drawing/2014/main" id="{3A2BFB00-E46F-CCBC-A5E4-5E73F00DA65C}"/>
-              </a:ext>
-            </a:extLst>
-          </p:cNvPr>
+          <p:cNvPr id="28" name="Google Shape;138;p16"/>
           <p:cNvSpPr/>
           <p:nvPr/>
         </p:nvSpPr>
@@ -28835,13 +28704,7 @@
       </p:sp>
       <p:sp>
         <p:nvSpPr>
-          <p:cNvPr id="30" name="Google Shape;167;p18">
-            <a:extLst>
-              <a:ext uri="{FF2B5EF4-FFF2-40B4-BE49-F238E27FC236}">
-                <a16:creationId xmlns:a16="http://schemas.microsoft.com/office/drawing/2014/main" id="{2B32F390-D8A7-F995-5A53-7034BC0B405C}"/>
-              </a:ext>
-            </a:extLst>
-          </p:cNvPr>
+          <p:cNvPr id="30" name="Google Shape;167;p18"/>
           <p:cNvSpPr/>
           <p:nvPr/>
         </p:nvSpPr>
@@ -28882,7 +28745,7 @@
               </a:tabLst>
             </a:pPr>
             <a:r>
-              <a:rPr lang="en-US" sz="2400" b="1" dirty="0" err="1">
+              <a:rPr lang="en-US" sz="2400" b="1">
                 <a:solidFill>
                   <a:srgbClr val="0F172A"/>
                 </a:solidFill>
@@ -28891,7 +28754,7 @@
               <a:t>Encapsulamento</a:t>
             </a:r>
             <a:r>
-              <a:rPr lang="en-US" sz="2400" b="1" dirty="0">
+              <a:rPr lang="en-US" sz="2400" b="1">
                 <a:solidFill>
                   <a:srgbClr val="0F172A"/>
                 </a:solidFill>
@@ -28900,7 +28763,7 @@
               <a:t>: </a:t>
             </a:r>
             <a:r>
-              <a:rPr lang="en-US" sz="2400" b="1" dirty="0" err="1">
+              <a:rPr lang="en-US" sz="2400" b="1">
                 <a:solidFill>
                   <a:srgbClr val="0F172A"/>
                 </a:solidFill>
@@ -28909,7 +28772,7 @@
               <a:t>Perguntas</a:t>
             </a:r>
             <a:r>
-              <a:rPr lang="en-US" sz="2400" b="1" dirty="0">
+              <a:rPr lang="en-US" sz="2400" b="1">
                 <a:solidFill>
                   <a:srgbClr val="0F172A"/>
                 </a:solidFill>
@@ -28918,7 +28781,7 @@
               <a:t> </a:t>
             </a:r>
             <a:r>
-              <a:rPr lang="en-US" sz="2400" b="1" dirty="0" err="1">
+              <a:rPr lang="en-US" sz="2400" b="1">
                 <a:solidFill>
                   <a:srgbClr val="0F172A"/>
                 </a:solidFill>
@@ -28926,7 +28789,7 @@
               </a:rPr>
               <a:t>Frequentes</a:t>
             </a:r>
-            <a:endParaRPr lang="en-US" sz="2400" dirty="0" err="1">
+            <a:endParaRPr lang="en-US" sz="2400">
               <a:solidFill>
                 <a:srgbClr val="000000"/>
               </a:solidFill>
@@ -28936,11 +28799,6 @@
         </p:txBody>
       </p:sp>
     </p:spTree>
-    <p:extLst>
-      <p:ext uri="{BB962C8B-B14F-4D97-AF65-F5344CB8AC3E}">
-        <p14:creationId xmlns:p14="http://schemas.microsoft.com/office/powerpoint/2010/main" val="3249075610"/>
-      </p:ext>
-    </p:extLst>
   </p:cSld>
   <p:clrMapOvr>
     <a:masterClrMapping/>
@@ -29174,7 +29032,7 @@
 </file>
 
 <file path=ppt/theme/theme1.xml><?xml version="1.0" encoding="utf-8"?>
-<a:theme xmlns:a="http://schemas.openxmlformats.org/drawingml/2006/main" name="Office Theme">
+<a:theme xmlns:a="http://schemas.openxmlformats.org/drawingml/2006/main" xmlns:r="http://schemas.openxmlformats.org/officeDocument/2006/relationships" name="Office Theme">
   <a:themeElements>
     <a:clrScheme name="Office">
       <a:dk1>
@@ -29407,7 +29265,7 @@
       </a:bgFillStyleLst>
     </a:fmtScheme>
   </a:themeElements>
-  <a:objectDefaults/>
-  <a:extraClrSchemeLst/>
+  <a:objectDefaults xmlns:a="http://schemas.openxmlformats.org/drawingml/2006/main"/>
+  <a:extraClrSchemeLst xmlns:a="http://schemas.openxmlformats.org/drawingml/2006/main"/>
 </a:theme>
 </file>
</xml_diff>